<commit_message>
Update into to deep learning slides
</commit_message>
<xml_diff>
--- a/slides/intro_to_deep_learning.pptx
+++ b/slides/intro_to_deep_learning.pptx
@@ -142,6 +142,35 @@
     </p:ext>
   </p:extLst>
 </p:presentation>
+</file>
+
+<file path=ppt/changesInfos/changesInfo1.xml><?xml version="1.0" encoding="utf-8"?>
+<pc:chgInfo xmlns:a="http://schemas.openxmlformats.org/drawingml/2006/main" xmlns:r="http://schemas.openxmlformats.org/officeDocument/2006/relationships" xmlns:ac="http://schemas.microsoft.com/office/drawing/2013/main/command" xmlns:pc="http://schemas.microsoft.com/office/powerpoint/2013/main/command">
+  <pc:docChgLst>
+    <pc:chgData name="Bradley Martin" userId="f8e117e3-5a7e-48dd-9ad1-65645ed54438" providerId="ADAL" clId="{C5D7457D-9C93-4A7E-BA4C-910ECB6C291C}"/>
+    <pc:docChg chg="modSld">
+      <pc:chgData name="Bradley Martin" userId="f8e117e3-5a7e-48dd-9ad1-65645ed54438" providerId="ADAL" clId="{C5D7457D-9C93-4A7E-BA4C-910ECB6C291C}" dt="2026-07-29T13:32:42.545" v="1" actId="115"/>
+      <pc:docMkLst>
+        <pc:docMk/>
+      </pc:docMkLst>
+      <pc:sldChg chg="modSp mod">
+        <pc:chgData name="Bradley Martin" userId="f8e117e3-5a7e-48dd-9ad1-65645ed54438" providerId="ADAL" clId="{C5D7457D-9C93-4A7E-BA4C-910ECB6C291C}" dt="2026-07-29T13:32:42.545" v="1" actId="115"/>
+        <pc:sldMkLst>
+          <pc:docMk/>
+          <pc:sldMk cId="3052936034" sldId="257"/>
+        </pc:sldMkLst>
+        <pc:spChg chg="mod">
+          <ac:chgData name="Bradley Martin" userId="f8e117e3-5a7e-48dd-9ad1-65645ed54438" providerId="ADAL" clId="{C5D7457D-9C93-4A7E-BA4C-910ECB6C291C}" dt="2026-07-29T13:32:42.545" v="1" actId="115"/>
+          <ac:spMkLst>
+            <pc:docMk/>
+            <pc:sldMk cId="3052936034" sldId="257"/>
+            <ac:spMk id="21" creationId="{9C8666DD-AC7F-9B03-33EE-26F7B383C8FF}"/>
+          </ac:spMkLst>
+        </pc:spChg>
+      </pc:sldChg>
+    </pc:docChg>
+  </pc:docChgLst>
+</pc:chgInfo>
 </file>
 
 <file path=ppt/notesMasters/notesMaster1.xml><?xml version="1.0" encoding="utf-8"?>
@@ -37034,34 +37063,38 @@
               <a:t>Practical notebooks: </a:t>
             </a:r>
             <a:r>
-              <a:rPr lang="en-GB" sz="1800" dirty="0" err="1"/>
+              <a:rPr lang="en-GB" sz="1800" u="sng" dirty="0" err="1"/>
               <a:t>load_and</a:t>
             </a:r>
             <a:r>
+              <a:rPr lang="en-GB" sz="1800" u="sng" dirty="0"/>
+              <a:t> </a:t>
+            </a:r>
+            <a:r>
+              <a:rPr lang="en-GB" sz="1800" u="sng" dirty="0" err="1"/>
+              <a:t>generate.ipynb</a:t>
+            </a:r>
+            <a:r>
+              <a:rPr lang="en-GB" sz="1800" u="sng" dirty="0"/>
+              <a:t> </a:t>
+            </a:r>
+            <a:r>
               <a:rPr lang="en-GB" sz="1800" dirty="0"/>
+              <a:t>and </a:t>
+            </a:r>
+            <a:r>
+              <a:rPr lang="en-GB" sz="1800" u="sng" dirty="0" err="1"/>
+              <a:t>Z_finetune_and</a:t>
+            </a:r>
+            <a:r>
+              <a:rPr lang="en-GB" sz="1800" u="sng" dirty="0"/>
               <a:t> </a:t>
             </a:r>
             <a:r>
-              <a:rPr lang="en-GB" sz="1800" dirty="0" err="1"/>
-              <a:t>generate.ipynb</a:t>
-            </a:r>
-            <a:r>
-              <a:rPr lang="en-GB" sz="1800" dirty="0"/>
-              <a:t> and </a:t>
-            </a:r>
-            <a:r>
-              <a:rPr lang="en-GB" sz="1800" dirty="0" err="1"/>
-              <a:t>Z_finetune_and</a:t>
-            </a:r>
-            <a:r>
-              <a:rPr lang="en-GB" sz="1800" dirty="0"/>
-              <a:t> </a:t>
-            </a:r>
-            <a:r>
-              <a:rPr lang="en-GB" sz="1800" dirty="0" err="1"/>
+              <a:rPr lang="en-GB" sz="1800" u="sng" dirty="0" err="1"/>
               <a:t>conditioning.ipynb</a:t>
             </a:r>
-            <a:endParaRPr lang="en-GB" sz="1800" dirty="0"/>
+            <a:endParaRPr lang="en-GB" sz="1800" u="sng" dirty="0"/>
           </a:p>
         </p:txBody>
       </p:sp>

</xml_diff>